<commit_message>
Refactor display topology & input; disable presentation mode
- Add DisplayTopologyController for managing mirroring/extend
- Update InputHandler for single-keystroke terminal controls
- Refactor monitor and audience window management
- Temporarily disable presentation mode activation
- Improve resource cleanup and monitor refresh logic
- Update help text to reflect presentation mode status
- Add Windows publish script and launchSettings.json
- Minor code and comment improvements
</commit_message>
<xml_diff>
--- a/DeckMark/AgenticTerminal-presentation.deck.pptx
+++ b/DeckMark/AgenticTerminal-presentation.deck.pptx
@@ -2,26 +2,26 @@
 <file path=ppt/presentation.xml><?xml version="1.0" encoding="utf-8"?>
 <p:presentation xmlns:a="http://schemas.openxmlformats.org/drawingml/2006/main" xmlns:r="http://schemas.openxmlformats.org/officeDocument/2006/relationships" xmlns:p="http://schemas.openxmlformats.org/presentationml/2006/main">
   <p:sldMasterIdLst>
-    <p:sldMasterId id="2147483648" r:id="R8d040d70fb4f4519"/>
+    <p:sldMasterId id="2147483648" r:id="Rcd08a4dae2ef45b0"/>
   </p:sldMasterIdLst>
   <p:sldIdLst>
-    <p:sldId id="256" r:id="Re7c39ad342354a21"/>
-    <p:sldId id="257" r:id="R4b1ffa30187a4607"/>
-    <p:sldId id="258" r:id="R9c76d2bf24e04725"/>
-    <p:sldId id="259" r:id="R36c3da80ccad416f"/>
-    <p:sldId id="260" r:id="R5ab6d6b24a3d40ec"/>
-    <p:sldId id="261" r:id="R2a9ba5d135404e1e"/>
-    <p:sldId id="262" r:id="R143eb0a3a0cc4c1a"/>
-    <p:sldId id="263" r:id="Rcb8a118af0804cc2"/>
-    <p:sldId id="264" r:id="Rf2682b8b0cdd444e"/>
-    <p:sldId id="265" r:id="R0826567f93fc43be"/>
-    <p:sldId id="266" r:id="Ra61f1d843595429f"/>
-    <p:sldId id="267" r:id="R40bc7b030f7c4694"/>
-    <p:sldId id="268" r:id="R63ad251789a8410d"/>
-    <p:sldId id="269" r:id="Red147dd2a33148e4"/>
-    <p:sldId id="270" r:id="Ra32e08348ab54338"/>
-    <p:sldId id="271" r:id="Rf80b7b3500144abc"/>
-    <p:sldId id="272" r:id="R9b163fd0eb114f9d"/>
+    <p:sldId id="256" r:id="R522e620d75b64d57"/>
+    <p:sldId id="257" r:id="R5914bc9e8a184a87"/>
+    <p:sldId id="258" r:id="R491542ab565f45f8"/>
+    <p:sldId id="259" r:id="Rb0b1fa1db0eb448e"/>
+    <p:sldId id="260" r:id="R86d4f5533b354cc1"/>
+    <p:sldId id="261" r:id="R120af9df0ccd40ec"/>
+    <p:sldId id="262" r:id="R55cf47c3511e483b"/>
+    <p:sldId id="263" r:id="Rd9b125209e14449e"/>
+    <p:sldId id="264" r:id="R6738bcf30bcc4180"/>
+    <p:sldId id="265" r:id="R4683909d421a4a1b"/>
+    <p:sldId id="266" r:id="R98c90f7b7a664ce9"/>
+    <p:sldId id="267" r:id="R38711e14ee624b0c"/>
+    <p:sldId id="268" r:id="Rdad285e2b98c41d3"/>
+    <p:sldId id="269" r:id="R86602bfc810c48e9"/>
+    <p:sldId id="270" r:id="R202598f27b7543cc"/>
+    <p:sldId id="271" r:id="R89f07a7083ff4558"/>
+    <p:sldId id="272" r:id="R61ee6fa374a74904"/>
   </p:sldIdLst>
   <p:sldSz cx="9144000" cy="5143500"/>
   <p:notesSz cx="6858000" cy="9144000"/>
@@ -144,7 +144,7 @@
   </p:cSld>
   <p:clrMap bg1="lt1" tx1="dk1" bg2="lt2" tx2="dk2" accent1="accent1" accent2="accent2" accent3="accent3" accent4="accent4" accent5="accent5" accent6="accent6" hlink="hlink" folHlink="folHlink"/>
   <p:sldLayoutIdLst>
-    <p:sldLayoutId id="2147483649" r:id="R27f0284a4a994f9e"/>
+    <p:sldLayoutId id="2147483649" r:id="R0111b40d968e4111"/>
   </p:sldLayoutIdLst>
   <p:txStyles>
     <p:titleStyle/>
@@ -377,6 +377,9 @@
   <p:clrMapOvr>
     <a:masterClrMapping/>
   </p:clrMapOvr>
+  <p:transition>
+    <p:random/>
+  </p:transition>
 </p:sld>
 </file>
 
@@ -607,6 +610,9 @@
   <p:clrMapOvr>
     <a:masterClrMapping/>
   </p:clrMapOvr>
+  <p:transition>
+    <p:random/>
+  </p:transition>
 </p:sld>
 </file>
 
@@ -877,6 +883,9 @@
   <p:clrMapOvr>
     <a:masterClrMapping/>
   </p:clrMapOvr>
+  <p:transition>
+    <p:random/>
+  </p:transition>
 </p:sld>
 </file>
 
@@ -978,6 +987,9 @@
   <p:clrMapOvr>
     <a:masterClrMapping/>
   </p:clrMapOvr>
+  <p:transition>
+    <p:random/>
+  </p:transition>
 </p:sld>
 </file>
 
@@ -1151,6 +1163,9 @@
   <p:clrMapOvr>
     <a:masterClrMapping/>
   </p:clrMapOvr>
+  <p:transition>
+    <p:random/>
+  </p:transition>
 </p:sld>
 </file>
 
@@ -1252,6 +1267,9 @@
   <p:clrMapOvr>
     <a:masterClrMapping/>
   </p:clrMapOvr>
+  <p:transition>
+    <p:random/>
+  </p:transition>
 </p:sld>
 </file>
 
@@ -1360,6 +1378,9 @@
   <p:clrMapOvr>
     <a:masterClrMapping/>
   </p:clrMapOvr>
+  <p:transition>
+    <p:random/>
+  </p:transition>
 </p:sld>
 </file>
 
@@ -1497,6 +1518,9 @@
   <p:clrMapOvr>
     <a:masterClrMapping/>
   </p:clrMapOvr>
+  <p:transition>
+    <p:random/>
+  </p:transition>
 </p:sld>
 </file>
 
@@ -1581,6 +1605,9 @@
   <p:clrMapOvr>
     <a:masterClrMapping/>
   </p:clrMapOvr>
+  <p:transition>
+    <p:random/>
+  </p:transition>
 </p:sld>
 </file>
 
@@ -1711,6 +1738,9 @@
   <p:clrMapOvr>
     <a:masterClrMapping/>
   </p:clrMapOvr>
+  <p:transition>
+    <p:random/>
+  </p:transition>
 </p:sld>
 </file>
 
@@ -1823,7 +1853,7 @@
           <p:nvPr/>
         </p:nvPicPr>
         <p:blipFill>
-          <a:blip r:embed="R62a6090371104edd"/>
+          <a:blip r:embed="R86cccb280cf64869"/>
           <a:stretch>
             <a:fillRect l="0" t="0" r="0" b="0"/>
           </a:stretch>
@@ -1841,6 +1871,9 @@
   <p:clrMapOvr>
     <a:masterClrMapping/>
   </p:clrMapOvr>
+  <p:transition>
+    <p:random/>
+  </p:transition>
 </p:sld>
 </file>
 
@@ -2043,7 +2076,7 @@
           <p:nvPr/>
         </p:nvPicPr>
         <p:blipFill>
-          <a:blip r:embed="Rdcfe67bcfc02452a"/>
+          <a:blip r:embed="R06a422e08c3e47b2"/>
           <a:stretch>
             <a:fillRect l="0" t="0" r="0" b="0"/>
           </a:stretch>
@@ -2061,6 +2094,9 @@
   <p:clrMapOvr>
     <a:masterClrMapping/>
   </p:clrMapOvr>
+  <p:transition>
+    <p:random/>
+  </p:transition>
 </p:sld>
 </file>
 
@@ -2163,6 +2199,9 @@
   <p:clrMapOvr>
     <a:masterClrMapping/>
   </p:clrMapOvr>
+  <p:transition>
+    <p:random/>
+  </p:transition>
 </p:sld>
 </file>
 
@@ -2214,7 +2253,7 @@
           <p:nvPr/>
         </p:nvPicPr>
         <p:blipFill>
-          <a:blip r:embed="Re1d83afd30e243b1"/>
+          <a:blip r:embed="Re304135a209244e9"/>
           <a:stretch>
             <a:fillRect l="0" t="0" r="0" b="0"/>
           </a:stretch>
@@ -2232,6 +2271,9 @@
   <p:clrMapOvr>
     <a:masterClrMapping/>
   </p:clrMapOvr>
+  <p:transition>
+    <p:random/>
+  </p:transition>
 </p:sld>
 </file>
 
@@ -2427,7 +2469,7 @@
           <p:nvPr/>
         </p:nvPicPr>
         <p:blipFill>
-          <a:blip r:embed="R89cc0ae43ceb4a47"/>
+          <a:blip r:embed="Rc4c7385c980d4822"/>
           <a:stretch>
             <a:fillRect l="0" t="0" r="0" b="0"/>
           </a:stretch>
@@ -2445,6 +2487,9 @@
   <p:clrMapOvr>
     <a:masterClrMapping/>
   </p:clrMapOvr>
+  <p:transition>
+    <p:random/>
+  </p:transition>
 </p:sld>
 </file>
 
@@ -2571,6 +2616,9 @@
   <p:clrMapOvr>
     <a:masterClrMapping/>
   </p:clrMapOvr>
+  <p:transition>
+    <p:random/>
+  </p:transition>
 </p:sld>
 </file>
 
@@ -2622,7 +2670,7 @@
           <p:nvPr/>
         </p:nvPicPr>
         <p:blipFill>
-          <a:blip r:embed="Ra898a47da9714501"/>
+          <a:blip r:embed="Rae66582c6f1f4712"/>
           <a:stretch>
             <a:fillRect l="0" t="0" r="0" b="0"/>
           </a:stretch>
@@ -2640,5 +2688,8 @@
   <p:clrMapOvr>
     <a:masterClrMapping/>
   </p:clrMapOvr>
+  <p:transition>
+    <p:random/>
+  </p:transition>
 </p:sld>
 </file>
</xml_diff>